<commit_message>
Add German versions of the Stow and Pick trainings
Co-Authored-By: Claude Opus 5.5 <noreply@anthropic.com>
Claude-Session: https://claude.ai/code/session_01Cr6d8mb1XkHfhN1yyjHEjG
</commit_message>
<xml_diff>
--- a/APMT_Coaching_Pick_to_Rebin_AR.pptx
+++ b/APMT_Coaching_Pick_to_Rebin_AR.pptx
@@ -119,7 +119,7 @@
   <p:extLst>
     <p:ext uri="{521415D9-36F7-43E2-AB2F-B90AF26B5E84}">
       <p14:sectionLst xmlns:p14="http://schemas.microsoft.com/office/powerpoint/2010/main">
-        <p14:section name="Intro" id="{7cca0b5b-6017-ec76-5c48-51bb8ce3915e}">
+        <p14:section name="Intro" id="{c4a788d2-f048-b92d-b847-ba0c93d3ecce}">
           <p14:sldIdLst>
             <p14:sldId id="256"/>
             <p14:sldId id="257"/>
@@ -128,7 +128,7 @@
             <p14:sldId id="260"/>
           </p14:sldIdLst>
         </p14:section>
-        <p14:section name="Bin etiquette" id="{c829d761-8161-5170-6363-8cb265a22dcb}">
+        <p14:section name="Bin etiquette" id="{2bbd884c-486c-1fbc-2e36-f10001f603e4}">
           <p14:sldIdLst>
             <p14:sldId id="261"/>
             <p14:sldId id="262"/>
@@ -138,7 +138,7 @@
             <p14:sldId id="266"/>
           </p14:sldIdLst>
         </p14:section>
-        <p14:section name="Wrap-up" id="{51344186-5a4a-3703-8a7b-bd5d3c2d88f6}">
+        <p14:section name="Wrap-up" id="{4277e96c-7736-7149-ef6c-d72ad12dd44f}">
           <p14:sldIdLst>
             <p14:sldId id="267"/>
             <p14:sldId id="268"/>

</xml_diff>